<commit_message>
docs: sync PPT closing slide with Kaede-Ayaki and v0.4.0
</commit_message>
<xml_diff>
--- a/docs/dsh-holo-memory-intro.pptx
+++ b/docs/dsh-holo-memory-intro.pptx
@@ -12002,7 +12002,7 @@
                 <a:ea typeface="Consolas"/>
                 <a:cs typeface="Consolas"/>
               </a:rPr>
-              <a:t>v0.3.0  ·  2026.10</a:t>
+              <a:t>v0.4.0  ·  2026.10</a:t>
             </a:r>
           </a:p>
         </p:txBody>
@@ -12046,7 +12046,7 @@
                 <a:ea typeface="Microsoft YaHei"/>
                 <a:cs typeface="Microsoft YaHei"/>
               </a:rPr>
-              <a:t>测试 24/24  ·  RRF / Active Window / Citation / Bands</a:t>
+              <a:t>测试 31/31  ·  Source / Revision / Doctor / RRF</a:t>
             </a:r>
           </a:p>
         </p:txBody>

</xml_diff>